<commit_message>
Add box-plot outlier analysis and update mid-review slides
Flag outliers on frame count and file size via IQR across the 5,000
videos in use (real + 4 manipulation methods); add a deck slide with
the chart and results, and refresh the STATUS slide now that dataset
download and a preprocessing dry-run are done.
</commit_message>
<xml_diff>
--- a/docs/mid_review_update.pptx
+++ b/docs/mid_review_update.pptx
@@ -12,6 +12,7 @@
     <p:sldId id="260" r:id="rId11"/>
     <p:sldId id="261" r:id="rId12"/>
     <p:sldId id="262" r:id="rId13"/>
+    <p:sldId id="264" r:id="rId15"/>
     <p:sldId id="263" r:id="rId14"/>
   </p:sldIdLst>
   <p:sldSz cx="12191695" cy="6858000" type="screen4x3"/>
@@ -4218,7 +4219,7 @@
                 </a:solidFill>
                 <a:latin typeface="Calibri"/>
               </a:rPr>
-              <a:t>2/8</a:t>
+              <a:t>2/9</a:t>
             </a:r>
           </a:p>
         </p:txBody>
@@ -5465,7 +5466,7 @@
                 </a:solidFill>
                 <a:latin typeface="Calibri"/>
               </a:rPr>
-              <a:t>3/8</a:t>
+              <a:t>3/9</a:t>
             </a:r>
           </a:p>
         </p:txBody>
@@ -6568,7 +6569,7 @@
                 </a:solidFill>
                 <a:latin typeface="Calibri"/>
               </a:rPr>
-              <a:t>4/8</a:t>
+              <a:t>4/9</a:t>
             </a:r>
           </a:p>
         </p:txBody>
@@ -6933,11 +6934,11 @@
           <a:p>
             <a:pPr algn="l">
               <a:spcAft>
-                <a:spcPts val="1000"/>
+                <a:spcPts val="1400"/>
               </a:spcAft>
             </a:pPr>
             <a:r>
-              <a:rPr sz="1250" b="1" i="0">
+              <a:rPr sz="1250" b="1">
                 <a:solidFill>
                   <a:srgbClr val="16A34A"/>
                 </a:solidFill>
@@ -6946,7 +6947,7 @@
               <a:t>▸  </a:t>
             </a:r>
             <a:r>
-              <a:rPr sz="1250" b="0" i="0">
+              <a:rPr sz="1250" b="0">
                 <a:solidFill>
                   <a:srgbClr val="1A202C"/>
                 </a:solidFill>
@@ -6958,11 +6959,11 @@
           <a:p>
             <a:pPr>
               <a:spcAft>
-                <a:spcPts val="1000"/>
+                <a:spcPts val="1400"/>
               </a:spcAft>
             </a:pPr>
             <a:r>
-              <a:rPr sz="1250" b="1" i="0">
+              <a:rPr sz="1250" b="1">
                 <a:solidFill>
                   <a:srgbClr val="16A34A"/>
                 </a:solidFill>
@@ -6971,7 +6972,7 @@
               <a:t>▸  </a:t>
             </a:r>
             <a:r>
-              <a:rPr sz="1250" b="0" i="0">
+              <a:rPr sz="1250" b="0">
                 <a:solidFill>
                   <a:srgbClr val="1A202C"/>
                 </a:solidFill>
@@ -6983,11 +6984,11 @@
           <a:p>
             <a:pPr>
               <a:spcAft>
-                <a:spcPts val="1000"/>
+                <a:spcPts val="1400"/>
               </a:spcAft>
             </a:pPr>
             <a:r>
-              <a:rPr sz="1250" b="1" i="0">
+              <a:rPr sz="1250" b="1">
                 <a:solidFill>
                   <a:srgbClr val="16A34A"/>
                 </a:solidFill>
@@ -6996,7 +6997,7 @@
               <a:t>▸  </a:t>
             </a:r>
             <a:r>
-              <a:rPr sz="1250" b="0" i="0">
+              <a:rPr sz="1250" b="0">
                 <a:solidFill>
                   <a:srgbClr val="1A202C"/>
                 </a:solidFill>
@@ -7008,11 +7009,11 @@
           <a:p>
             <a:pPr>
               <a:spcAft>
-                <a:spcPts val="1000"/>
+                <a:spcPts val="1400"/>
               </a:spcAft>
             </a:pPr>
             <a:r>
-              <a:rPr sz="1250" b="1" i="0">
+              <a:rPr sz="1250" b="1">
                 <a:solidFill>
                   <a:srgbClr val="16A34A"/>
                 </a:solidFill>
@@ -7021,7 +7022,7 @@
               <a:t>▸  </a:t>
             </a:r>
             <a:r>
-              <a:rPr sz="1250" b="0" i="0">
+              <a:rPr sz="1250" b="0">
                 <a:solidFill>
                   <a:srgbClr val="1A202C"/>
                 </a:solidFill>
@@ -7033,11 +7034,11 @@
           <a:p>
             <a:pPr>
               <a:spcAft>
-                <a:spcPts val="1000"/>
+                <a:spcPts val="1400"/>
               </a:spcAft>
             </a:pPr>
             <a:r>
-              <a:rPr sz="1250" b="1" i="0">
+              <a:rPr sz="1250" b="1">
                 <a:solidFill>
                   <a:srgbClr val="16A34A"/>
                 </a:solidFill>
@@ -7046,7 +7047,7 @@
               <a:t>▸  </a:t>
             </a:r>
             <a:r>
-              <a:rPr sz="1250" b="0" i="0">
+              <a:rPr sz="1250" b="0">
                 <a:solidFill>
                   <a:srgbClr val="1A202C"/>
                 </a:solidFill>
@@ -7058,11 +7059,11 @@
           <a:p>
             <a:pPr>
               <a:spcAft>
-                <a:spcPts val="1000"/>
+                <a:spcPts val="1400"/>
               </a:spcAft>
             </a:pPr>
             <a:r>
-              <a:rPr sz="1250" b="1" i="0">
+              <a:rPr sz="1250" b="1">
                 <a:solidFill>
                   <a:srgbClr val="16A34A"/>
                 </a:solidFill>
@@ -7071,23 +7072,23 @@
               <a:t>▸  </a:t>
             </a:r>
             <a:r>
-              <a:rPr sz="1250" b="0" i="0">
+              <a:rPr sz="1250" b="0">
                 <a:solidFill>
                   <a:srgbClr val="1A202C"/>
                 </a:solidFill>
                 <a:latin typeface="Calibri"/>
               </a:rPr>
-              <a:t>Colab fallback notebook prepared as backup compute</a:t>
+              <a:t>Dataset downloaded (Kaggle c23 mirror) &amp; mapped to the official FF++ layout</a:t>
             </a:r>
           </a:p>
           <a:p>
             <a:pPr>
               <a:spcAft>
-                <a:spcPts val="1000"/>
+                <a:spcPts val="1400"/>
               </a:spcAft>
             </a:pPr>
             <a:r>
-              <a:rPr sz="1250" b="1" i="0">
+              <a:rPr sz="1250" b="1">
                 <a:solidFill>
                   <a:srgbClr val="16A34A"/>
                 </a:solidFill>
@@ -7096,13 +7097,38 @@
               <a:t>▸  </a:t>
             </a:r>
             <a:r>
-              <a:rPr sz="1250" b="0" i="0">
+              <a:rPr sz="1250" b="0">
                 <a:solidFill>
                   <a:srgbClr val="1A202C"/>
                 </a:solidFill>
                 <a:latin typeface="Calibri"/>
               </a:rPr>
-              <a:t>Code version-controlled and pushed to GitHub</a:t>
+              <a:t>Outliers checked via box plot (IQR) — 502 of 5,000 videos flagged</a:t>
+            </a:r>
+          </a:p>
+          <a:p>
+            <a:pPr>
+              <a:spcAft>
+                <a:spcPts val="1400"/>
+              </a:spcAft>
+            </a:pPr>
+            <a:r>
+              <a:rPr sz="1250" b="1">
+                <a:solidFill>
+                  <a:srgbClr val="16A34A"/>
+                </a:solidFill>
+                <a:latin typeface="Calibri"/>
+              </a:rPr>
+              <a:t>▸  </a:t>
+            </a:r>
+            <a:r>
+              <a:rPr sz="1250" b="0">
+                <a:solidFill>
+                  <a:srgbClr val="1A202C"/>
+                </a:solidFill>
+                <a:latin typeface="Calibri"/>
+              </a:rPr>
+              <a:t>Preprocessing dry-run verified: MTCNN face crops confirmed on GPU</a:t>
             </a:r>
           </a:p>
         </p:txBody>
@@ -7260,7 +7286,7 @@
               </a:spcAft>
             </a:pPr>
             <a:r>
-              <a:rPr sz="1250" b="1" i="0">
+              <a:rPr sz="1250" b="1">
                 <a:solidFill>
                   <a:srgbClr val="F59E0B"/>
                 </a:solidFill>
@@ -7269,22 +7295,22 @@
               <a:t>▸  </a:t>
             </a:r>
             <a:r>
-              <a:rPr sz="1250" b="1" i="0">
+              <a:rPr sz="1250" b="1">
                 <a:solidFill>
                   <a:srgbClr val="1A202C"/>
                 </a:solidFill>
                 <a:latin typeface="Calibri"/>
               </a:rPr>
-              <a:t>Dataset access: </a:t>
-            </a:r>
-            <a:r>
-              <a:rPr sz="1250" b="0" i="0">
+              <a:t>Full preprocessing: </a:t>
+            </a:r>
+            <a:r>
+              <a:rPr sz="1250" b="0">
                 <a:solidFill>
                   <a:srgbClr val="1A202C"/>
                 </a:solidFill>
                 <a:latin typeface="Calibri"/>
               </a:rPr>
-              <a:t>official FF++ form submitted, approval pending (~days)</a:t>
+              <a:t>extracting face crops for all ~5,000 videos</a:t>
             </a:r>
           </a:p>
           <a:p>
@@ -7294,7 +7320,7 @@
               </a:spcAft>
             </a:pPr>
             <a:r>
-              <a:rPr sz="1250" b="1" i="0">
+              <a:rPr sz="1250" b="1">
                 <a:solidFill>
                   <a:srgbClr val="F59E0B"/>
                 </a:solidFill>
@@ -7303,22 +7329,22 @@
               <a:t>▸  </a:t>
             </a:r>
             <a:r>
-              <a:rPr sz="1250" b="1" i="0">
+              <a:rPr sz="1250" b="1">
                 <a:solidFill>
                   <a:srgbClr val="1A202C"/>
                 </a:solidFill>
                 <a:latin typeface="Calibri"/>
               </a:rPr>
-              <a:t>Dataset bridge: </a:t>
-            </a:r>
-            <a:r>
-              <a:rPr sz="1250" b="0" i="0">
+              <a:t>Training runs: </a:t>
+            </a:r>
+            <a:r>
+              <a:rPr sz="1250" b="0">
                 <a:solidFill>
                   <a:srgbClr val="1A202C"/>
                 </a:solidFill>
                 <a:latin typeface="Calibri"/>
               </a:rPr>
-              <a:t>Kaggle mirror identified for c23 data, download next</a:t>
+              <a:t>12 training runs across both models, not yet started</a:t>
             </a:r>
           </a:p>
           <a:p>
@@ -7328,7 +7354,7 @@
               </a:spcAft>
             </a:pPr>
             <a:r>
-              <a:rPr sz="1250" b="1" i="0">
+              <a:rPr sz="1250" b="1">
                 <a:solidFill>
                   <a:srgbClr val="F59E0B"/>
                 </a:solidFill>
@@ -7337,22 +7363,22 @@
               <a:t>▸  </a:t>
             </a:r>
             <a:r>
-              <a:rPr sz="1250" b="1" i="0">
+              <a:rPr sz="1250" b="1">
                 <a:solidFill>
                   <a:srgbClr val="1A202C"/>
                 </a:solidFill>
                 <a:latin typeface="Calibri"/>
               </a:rPr>
-              <a:t>Not yet started: </a:t>
-            </a:r>
-            <a:r>
-              <a:rPr sz="1250" b="0" i="0">
+              <a:t>Evaluation &amp; analysis: </a:t>
+            </a:r>
+            <a:r>
+              <a:rPr sz="1250" b="0">
                 <a:solidFill>
                   <a:srgbClr val="1A202C"/>
                 </a:solidFill>
                 <a:latin typeface="Calibri"/>
               </a:rPr>
-              <a:t>preprocessing, training runs, evaluation, analysis</a:t>
+              <a:t>cross-manipulation + compression experiments</a:t>
             </a:r>
           </a:p>
         </p:txBody>
@@ -7422,7 +7448,7 @@
                 </a:solidFill>
                 <a:latin typeface="Calibri"/>
               </a:rPr>
-              <a:t>5/8</a:t>
+              <a:t>5/9</a:t>
             </a:r>
           </a:p>
         </p:txBody>
@@ -9432,7 +9458,7 @@
                 </a:solidFill>
                 <a:latin typeface="Calibri"/>
               </a:rPr>
-              <a:t>6/8</a:t>
+              <a:t>6/9</a:t>
             </a:r>
           </a:p>
         </p:txBody>
@@ -10281,7 +10307,7 @@
                 </a:solidFill>
                 <a:latin typeface="Calibri"/>
               </a:rPr>
-              <a:t>7/8</a:t>
+              <a:t>7/9</a:t>
             </a:r>
           </a:p>
         </p:txBody>
@@ -10319,6 +10345,784 @@
             <a:avLst/>
           </a:prstGeom>
           <a:solidFill>
+            <a:srgbClr val="FFFFFF"/>
+          </a:solidFill>
+          <a:ln>
+            <a:noFill/>
+          </a:ln>
+          <a:effectLst/>
+        </p:spPr>
+        <p:style>
+          <a:lnRef idx="1">
+            <a:schemeClr val="accent1"/>
+          </a:lnRef>
+          <a:fillRef idx="3">
+            <a:schemeClr val="accent1"/>
+          </a:fillRef>
+          <a:effectRef idx="2">
+            <a:schemeClr val="accent1"/>
+          </a:effectRef>
+          <a:fontRef idx="minor">
+            <a:schemeClr val="lt1"/>
+          </a:fontRef>
+        </p:style>
+        <p:txBody>
+          <a:bodyPr rtlCol="0" anchor="ctr"/>
+          <a:lstStyle/>
+          <a:p>
+            <a:pPr algn="ctr"/>
+          </a:p>
+        </p:txBody>
+      </p:sp>
+      <p:sp>
+        <p:nvSpPr>
+          <p:cNvPr id="3" name="TextBox 2"/>
+          <p:cNvSpPr txBox="1"/>
+          <p:nvPr/>
+        </p:nvSpPr>
+        <p:spPr>
+          <a:xfrm>
+            <a:off x="640080" y="384048"/>
+            <a:ext cx="9144000" cy="320040"/>
+          </a:xfrm>
+          <a:prstGeom prst="rect">
+            <a:avLst/>
+          </a:prstGeom>
+          <a:noFill/>
+        </p:spPr>
+        <p:txBody>
+          <a:bodyPr wrap="square" lIns="0" rIns="0" tIns="0" bIns="0">
+            <a:spAutoFit/>
+          </a:bodyPr>
+          <a:lstStyle/>
+          <a:p>
+            <a:pPr algn="l"/>
+            <a:r>
+              <a:rPr sz="1300" b="1">
+                <a:solidFill>
+                  <a:srgbClr val="0E7490"/>
+                </a:solidFill>
+                <a:latin typeface="Calibri"/>
+              </a:rPr>
+              <a:t>DATA QUALITY</a:t>
+            </a:r>
+          </a:p>
+        </p:txBody>
+      </p:sp>
+      <p:sp>
+        <p:nvSpPr>
+          <p:cNvPr id="4" name="TextBox 3"/>
+          <p:cNvSpPr txBox="1"/>
+          <p:nvPr/>
+        </p:nvSpPr>
+        <p:spPr>
+          <a:xfrm>
+            <a:off x="640080" y="658368"/>
+            <a:ext cx="10515600" cy="640080"/>
+          </a:xfrm>
+          <a:prstGeom prst="rect">
+            <a:avLst/>
+          </a:prstGeom>
+          <a:noFill/>
+        </p:spPr>
+        <p:txBody>
+          <a:bodyPr wrap="square" lIns="0" rIns="0" tIns="0" bIns="0">
+            <a:spAutoFit/>
+          </a:bodyPr>
+          <a:lstStyle/>
+          <a:p>
+            <a:pPr algn="l"/>
+            <a:r>
+              <a:rPr sz="3000" b="1">
+                <a:solidFill>
+                  <a:srgbClr val="1A202C"/>
+                </a:solidFill>
+                <a:latin typeface="Calibri"/>
+              </a:rPr>
+              <a:t>Outlier Removal via Box Plot (IQR)</a:t>
+            </a:r>
+          </a:p>
+        </p:txBody>
+      </p:sp>
+      <p:sp>
+        <p:nvSpPr>
+          <p:cNvPr id="5" name="Rectangle 4"/>
+          <p:cNvSpPr/>
+          <p:nvPr/>
+        </p:nvSpPr>
+        <p:spPr>
+          <a:xfrm>
+            <a:off x="640080" y="1353312"/>
+            <a:ext cx="502920" cy="41148"/>
+          </a:xfrm>
+          <a:prstGeom prst="rect">
+            <a:avLst/>
+          </a:prstGeom>
+          <a:solidFill>
+            <a:srgbClr val="22B8CF"/>
+          </a:solidFill>
+          <a:ln>
+            <a:noFill/>
+          </a:ln>
+          <a:effectLst/>
+        </p:spPr>
+        <p:style>
+          <a:lnRef idx="1">
+            <a:schemeClr val="accent1"/>
+          </a:lnRef>
+          <a:fillRef idx="3">
+            <a:schemeClr val="accent1"/>
+          </a:fillRef>
+          <a:effectRef idx="2">
+            <a:schemeClr val="accent1"/>
+          </a:effectRef>
+          <a:fontRef idx="minor">
+            <a:schemeClr val="lt1"/>
+          </a:fontRef>
+        </p:style>
+        <p:txBody>
+          <a:bodyPr rtlCol="0" anchor="ctr"/>
+          <a:lstStyle/>
+          <a:p>
+            <a:pPr algn="ctr"/>
+          </a:p>
+        </p:txBody>
+      </p:sp>
+      <p:sp>
+        <p:nvSpPr>
+          <p:cNvPr id="6" name="TextBox 5"/>
+          <p:cNvSpPr txBox="1"/>
+          <p:nvPr/>
+        </p:nvSpPr>
+        <p:spPr>
+          <a:xfrm>
+            <a:off x="640080" y="1691640"/>
+            <a:ext cx="10515600" cy="457200"/>
+          </a:xfrm>
+          <a:prstGeom prst="rect">
+            <a:avLst/>
+          </a:prstGeom>
+          <a:noFill/>
+        </p:spPr>
+        <p:txBody>
+          <a:bodyPr wrap="square" lIns="0" rIns="0" tIns="0" bIns="0">
+            <a:spAutoFit/>
+          </a:bodyPr>
+          <a:lstStyle/>
+          <a:p>
+            <a:pPr algn="l"/>
+            <a:r>
+              <a:rPr sz="1350" b="0">
+                <a:solidFill>
+                  <a:srgbClr val="475569"/>
+                </a:solidFill>
+                <a:latin typeface="Calibri"/>
+              </a:rPr>
+              <a:t>Per-video metadata (frame count, file size) from the FF++ Kaggle mirror, checked with Tukey's IQR method — flags anything beyond Q1 − 1.5×IQR / Q3 + 1.5×IQR.</a:t>
+            </a:r>
+          </a:p>
+        </p:txBody>
+      </p:sp>
+      <p:pic>
+        <p:nvPicPr>
+          <p:cNvPr id="7" name="Picture 6" descr="outlier_boxplots.png"/>
+          <p:cNvPicPr>
+            <a:picLocks noChangeAspect="1"/>
+          </p:cNvPicPr>
+          <p:nvPr/>
+        </p:nvPicPr>
+        <p:blipFill>
+          <a:blip r:embed="rId2"/>
+          <a:stretch>
+            <a:fillRect/>
+          </a:stretch>
+        </p:blipFill>
+        <p:spPr>
+          <a:xfrm>
+            <a:off x="640080" y="2286000"/>
+            <a:ext cx="7406640" cy="3648169"/>
+          </a:xfrm>
+          <a:prstGeom prst="rect">
+            <a:avLst/>
+          </a:prstGeom>
+        </p:spPr>
+      </p:pic>
+      <p:sp>
+        <p:nvSpPr>
+          <p:cNvPr id="8" name="Rectangle 7"/>
+          <p:cNvSpPr/>
+          <p:nvPr/>
+        </p:nvSpPr>
+        <p:spPr>
+          <a:xfrm>
+            <a:off x="8321040" y="2286000"/>
+            <a:ext cx="3200400" cy="4114800"/>
+          </a:xfrm>
+          <a:prstGeom prst="rect">
+            <a:avLst/>
+          </a:prstGeom>
+          <a:solidFill>
+            <a:srgbClr val="F1F5F9"/>
+          </a:solidFill>
+          <a:ln>
+            <a:noFill/>
+          </a:ln>
+          <a:effectLst/>
+        </p:spPr>
+        <p:style>
+          <a:lnRef idx="1">
+            <a:schemeClr val="accent1"/>
+          </a:lnRef>
+          <a:fillRef idx="3">
+            <a:schemeClr val="accent1"/>
+          </a:fillRef>
+          <a:effectRef idx="2">
+            <a:schemeClr val="accent1"/>
+          </a:effectRef>
+          <a:fontRef idx="minor">
+            <a:schemeClr val="lt1"/>
+          </a:fontRef>
+        </p:style>
+        <p:txBody>
+          <a:bodyPr rtlCol="0" anchor="ctr"/>
+          <a:lstStyle/>
+          <a:p>
+            <a:pPr algn="ctr"/>
+          </a:p>
+        </p:txBody>
+      </p:sp>
+      <p:sp>
+        <p:nvSpPr>
+          <p:cNvPr id="9" name="TextBox 8"/>
+          <p:cNvSpPr txBox="1"/>
+          <p:nvPr/>
+        </p:nvSpPr>
+        <p:spPr>
+          <a:xfrm>
+            <a:off x="8549640" y="2513965"/>
+            <a:ext cx="2743200" cy="320040"/>
+          </a:xfrm>
+          <a:prstGeom prst="rect">
+            <a:avLst/>
+          </a:prstGeom>
+          <a:noFill/>
+        </p:spPr>
+        <p:txBody>
+          <a:bodyPr wrap="square" lIns="0" rIns="0" tIns="0" bIns="0">
+            <a:spAutoFit/>
+          </a:bodyPr>
+          <a:lstStyle/>
+          <a:p>
+            <a:pPr algn="l"/>
+            <a:r>
+              <a:rPr sz="1100" b="1">
+                <a:solidFill>
+                  <a:srgbClr val="0E7490"/>
+                </a:solidFill>
+                <a:latin typeface="Calibri"/>
+              </a:rPr>
+              <a:t>RESULT</a:t>
+            </a:r>
+          </a:p>
+        </p:txBody>
+      </p:sp>
+      <p:sp>
+        <p:nvSpPr>
+          <p:cNvPr id="10" name="TextBox 9"/>
+          <p:cNvSpPr txBox="1"/>
+          <p:nvPr/>
+        </p:nvSpPr>
+        <p:spPr>
+          <a:xfrm>
+            <a:off x="8549640" y="2895600"/>
+            <a:ext cx="2743200" cy="365760"/>
+          </a:xfrm>
+          <a:prstGeom prst="rect">
+            <a:avLst/>
+          </a:prstGeom>
+          <a:noFill/>
+        </p:spPr>
+        <p:txBody>
+          <a:bodyPr wrap="square" lIns="0" rIns="0" tIns="0" bIns="0">
+            <a:spAutoFit/>
+          </a:bodyPr>
+          <a:lstStyle/>
+          <a:p>
+            <a:pPr algn="l"/>
+            <a:r>
+              <a:rPr sz="2200" b="1">
+                <a:solidFill>
+                  <a:srgbClr val="0F172A"/>
+                </a:solidFill>
+                <a:latin typeface="Calibri"/>
+              </a:rPr>
+              <a:t>5,000</a:t>
+            </a:r>
+          </a:p>
+        </p:txBody>
+      </p:sp>
+      <p:sp>
+        <p:nvSpPr>
+          <p:cNvPr id="11" name="TextBox 10"/>
+          <p:cNvSpPr txBox="1"/>
+          <p:nvPr/>
+        </p:nvSpPr>
+        <p:spPr>
+          <a:xfrm>
+            <a:off x="8549640" y="3252216"/>
+            <a:ext cx="2743200" cy="320040"/>
+          </a:xfrm>
+          <a:prstGeom prst="rect">
+            <a:avLst/>
+          </a:prstGeom>
+          <a:noFill/>
+        </p:spPr>
+        <p:txBody>
+          <a:bodyPr wrap="square" lIns="0" rIns="0" tIns="0" bIns="0">
+            <a:spAutoFit/>
+          </a:bodyPr>
+          <a:lstStyle/>
+          <a:p>
+            <a:pPr algn="l"/>
+            <a:r>
+              <a:rPr sz="1050" b="0">
+                <a:solidFill>
+                  <a:srgbClr val="475569"/>
+                </a:solidFill>
+                <a:latin typeface="Calibri"/>
+              </a:rPr>
+              <a:t>videos analyzed (real + 4 manipulation methods)</a:t>
+            </a:r>
+          </a:p>
+        </p:txBody>
+      </p:sp>
+      <p:sp>
+        <p:nvSpPr>
+          <p:cNvPr id="12" name="TextBox 11"/>
+          <p:cNvSpPr txBox="1"/>
+          <p:nvPr/>
+        </p:nvSpPr>
+        <p:spPr>
+          <a:xfrm>
+            <a:off x="8549640" y="3515600"/>
+            <a:ext cx="2743200" cy="365760"/>
+          </a:xfrm>
+          <a:prstGeom prst="rect">
+            <a:avLst/>
+          </a:prstGeom>
+          <a:noFill/>
+        </p:spPr>
+        <p:txBody>
+          <a:bodyPr wrap="square" lIns="0" rIns="0" tIns="0" bIns="0">
+            <a:spAutoFit/>
+          </a:bodyPr>
+          <a:lstStyle/>
+          <a:p>
+            <a:pPr algn="l"/>
+            <a:r>
+              <a:rPr sz="2200" b="1">
+                <a:solidFill>
+                  <a:srgbClr val="0F172A"/>
+                </a:solidFill>
+                <a:latin typeface="Calibri"/>
+              </a:rPr>
+              <a:t>209</a:t>
+            </a:r>
+          </a:p>
+        </p:txBody>
+      </p:sp>
+      <p:sp>
+        <p:nvSpPr>
+          <p:cNvPr id="13" name="TextBox 12"/>
+          <p:cNvSpPr txBox="1"/>
+          <p:nvPr/>
+        </p:nvSpPr>
+        <p:spPr>
+          <a:xfrm>
+            <a:off x="8549640" y="3872216"/>
+            <a:ext cx="2743200" cy="320040"/>
+          </a:xfrm>
+          <a:prstGeom prst="rect">
+            <a:avLst/>
+          </a:prstGeom>
+          <a:noFill/>
+        </p:spPr>
+        <p:txBody>
+          <a:bodyPr wrap="square" lIns="0" rIns="0" tIns="0" bIns="0">
+            <a:spAutoFit/>
+          </a:bodyPr>
+          <a:lstStyle/>
+          <a:p>
+            <a:pPr algn="l"/>
+            <a:r>
+              <a:rPr sz="1050" b="0">
+                <a:solidFill>
+                  <a:srgbClr val="475569"/>
+                </a:solidFill>
+                <a:latin typeface="Calibri"/>
+              </a:rPr>
+              <a:t>flagged on frame count (4.2%)</a:t>
+            </a:r>
+          </a:p>
+        </p:txBody>
+      </p:sp>
+      <p:sp>
+        <p:nvSpPr>
+          <p:cNvPr id="14" name="TextBox 13"/>
+          <p:cNvSpPr txBox="1"/>
+          <p:nvPr/>
+        </p:nvSpPr>
+        <p:spPr>
+          <a:xfrm>
+            <a:off x="8549640" y="4135600"/>
+            <a:ext cx="2743200" cy="365760"/>
+          </a:xfrm>
+          <a:prstGeom prst="rect">
+            <a:avLst/>
+          </a:prstGeom>
+          <a:noFill/>
+        </p:spPr>
+        <p:txBody>
+          <a:bodyPr wrap="square" lIns="0" rIns="0" tIns="0" bIns="0">
+            <a:spAutoFit/>
+          </a:bodyPr>
+          <a:lstStyle/>
+          <a:p>
+            <a:pPr algn="l"/>
+            <a:r>
+              <a:rPr sz="2200" b="1">
+                <a:solidFill>
+                  <a:srgbClr val="0F172A"/>
+                </a:solidFill>
+                <a:latin typeface="Calibri"/>
+              </a:rPr>
+              <a:t>326</a:t>
+            </a:r>
+          </a:p>
+        </p:txBody>
+      </p:sp>
+      <p:sp>
+        <p:nvSpPr>
+          <p:cNvPr id="15" name="TextBox 14"/>
+          <p:cNvSpPr txBox="1"/>
+          <p:nvPr/>
+        </p:nvSpPr>
+        <p:spPr>
+          <a:xfrm>
+            <a:off x="8549640" y="4492216"/>
+            <a:ext cx="2743200" cy="320040"/>
+          </a:xfrm>
+          <a:prstGeom prst="rect">
+            <a:avLst/>
+          </a:prstGeom>
+          <a:noFill/>
+        </p:spPr>
+        <p:txBody>
+          <a:bodyPr wrap="square" lIns="0" rIns="0" tIns="0" bIns="0">
+            <a:spAutoFit/>
+          </a:bodyPr>
+          <a:lstStyle/>
+          <a:p>
+            <a:pPr algn="l"/>
+            <a:r>
+              <a:rPr sz="1050" b="0">
+                <a:solidFill>
+                  <a:srgbClr val="475569"/>
+                </a:solidFill>
+                <a:latin typeface="Calibri"/>
+              </a:rPr>
+              <a:t>flagged on file size (6.5%)</a:t>
+            </a:r>
+          </a:p>
+        </p:txBody>
+      </p:sp>
+      <p:sp>
+        <p:nvSpPr>
+          <p:cNvPr id="16" name="TextBox 15"/>
+          <p:cNvSpPr txBox="1"/>
+          <p:nvPr/>
+        </p:nvSpPr>
+        <p:spPr>
+          <a:xfrm>
+            <a:off x="8549640" y="4755600"/>
+            <a:ext cx="2743200" cy="365760"/>
+          </a:xfrm>
+          <a:prstGeom prst="rect">
+            <a:avLst/>
+          </a:prstGeom>
+          <a:noFill/>
+        </p:spPr>
+        <p:txBody>
+          <a:bodyPr wrap="square" lIns="0" rIns="0" tIns="0" bIns="0">
+            <a:spAutoFit/>
+          </a:bodyPr>
+          <a:lstStyle/>
+          <a:p>
+            <a:pPr algn="l"/>
+            <a:r>
+              <a:rPr sz="2200" b="1">
+                <a:solidFill>
+                  <a:srgbClr val="0F172A"/>
+                </a:solidFill>
+                <a:latin typeface="Calibri"/>
+              </a:rPr>
+              <a:t>502</a:t>
+            </a:r>
+          </a:p>
+        </p:txBody>
+      </p:sp>
+      <p:sp>
+        <p:nvSpPr>
+          <p:cNvPr id="17" name="TextBox 16"/>
+          <p:cNvSpPr txBox="1"/>
+          <p:nvPr/>
+        </p:nvSpPr>
+        <p:spPr>
+          <a:xfrm>
+            <a:off x="8549640" y="5112216"/>
+            <a:ext cx="2743200" cy="320040"/>
+          </a:xfrm>
+          <a:prstGeom prst="rect">
+            <a:avLst/>
+          </a:prstGeom>
+          <a:noFill/>
+        </p:spPr>
+        <p:txBody>
+          <a:bodyPr wrap="square" lIns="0" rIns="0" tIns="0" bIns="0">
+            <a:spAutoFit/>
+          </a:bodyPr>
+          <a:lstStyle/>
+          <a:p>
+            <a:pPr algn="l"/>
+            <a:r>
+              <a:rPr sz="1050" b="0">
+                <a:solidFill>
+                  <a:srgbClr val="475569"/>
+                </a:solidFill>
+                <a:latin typeface="Calibri"/>
+              </a:rPr>
+              <a:t>unique outlier videos overall (10.0%)</a:t>
+            </a:r>
+          </a:p>
+        </p:txBody>
+      </p:sp>
+      <p:sp>
+        <p:nvSpPr>
+          <p:cNvPr id="18" name="Rectangle 17"/>
+          <p:cNvSpPr/>
+          <p:nvPr/>
+        </p:nvSpPr>
+        <p:spPr>
+          <a:xfrm>
+            <a:off x="8549640" y="5635600"/>
+            <a:ext cx="2743200" cy="18288"/>
+          </a:xfrm>
+          <a:prstGeom prst="rect">
+            <a:avLst/>
+          </a:prstGeom>
+          <a:solidFill>
+            <a:srgbClr val="E2E8F0"/>
+          </a:solidFill>
+          <a:ln>
+            <a:noFill/>
+          </a:ln>
+          <a:effectLst/>
+        </p:spPr>
+        <p:style>
+          <a:lnRef idx="1">
+            <a:schemeClr val="accent1"/>
+          </a:lnRef>
+          <a:fillRef idx="3">
+            <a:schemeClr val="accent1"/>
+          </a:fillRef>
+          <a:effectRef idx="2">
+            <a:schemeClr val="accent1"/>
+          </a:effectRef>
+          <a:fontRef idx="minor">
+            <a:schemeClr val="lt1"/>
+          </a:fontRef>
+        </p:style>
+        <p:txBody>
+          <a:bodyPr rtlCol="0" anchor="ctr"/>
+          <a:lstStyle/>
+          <a:p>
+            <a:pPr algn="ctr"/>
+          </a:p>
+        </p:txBody>
+      </p:sp>
+      <p:sp>
+        <p:nvSpPr>
+          <p:cNvPr id="19" name="TextBox 18"/>
+          <p:cNvSpPr txBox="1"/>
+          <p:nvPr/>
+        </p:nvSpPr>
+        <p:spPr>
+          <a:xfrm>
+            <a:off x="8549640" y="5415600"/>
+            <a:ext cx="2743200" cy="320040"/>
+          </a:xfrm>
+          <a:prstGeom prst="rect">
+            <a:avLst/>
+          </a:prstGeom>
+          <a:noFill/>
+        </p:spPr>
+        <p:txBody>
+          <a:bodyPr wrap="square" lIns="0" rIns="0" tIns="0" bIns="0">
+            <a:spAutoFit/>
+          </a:bodyPr>
+          <a:lstStyle/>
+          <a:p>
+            <a:pPr algn="l"/>
+            <a:r>
+              <a:rPr sz="1100" b="1">
+                <a:solidFill>
+                  <a:srgbClr val="0E7490"/>
+                </a:solidFill>
+                <a:latin typeface="Calibri"/>
+              </a:rPr>
+              <a:t>Action</a:t>
+            </a:r>
+          </a:p>
+        </p:txBody>
+      </p:sp>
+      <p:sp>
+        <p:nvSpPr>
+          <p:cNvPr id="20" name="TextBox 19"/>
+          <p:cNvSpPr txBox="1"/>
+          <p:nvPr/>
+        </p:nvSpPr>
+        <p:spPr>
+          <a:xfrm>
+            <a:off x="8549640" y="5715600"/>
+            <a:ext cx="2743200" cy="400000"/>
+          </a:xfrm>
+          <a:prstGeom prst="rect">
+            <a:avLst/>
+          </a:prstGeom>
+          <a:noFill/>
+        </p:spPr>
+        <p:txBody>
+          <a:bodyPr wrap="square" lIns="0" rIns="0" tIns="0" bIns="0">
+            <a:spAutoFit/>
+          </a:bodyPr>
+          <a:lstStyle/>
+          <a:p>
+            <a:pPr algn="l"/>
+            <a:r>
+              <a:rPr sz="1150" b="0">
+                <a:solidFill>
+                  <a:srgbClr val="1A202C"/>
+                </a:solidFill>
+                <a:latin typeface="Calibri"/>
+              </a:rPr>
+              <a:t>Excluded before preprocessing — clean set: 4,498 videos.</a:t>
+            </a:r>
+          </a:p>
+        </p:txBody>
+      </p:sp>
+      <p:sp>
+        <p:nvSpPr>
+          <p:cNvPr id="21" name="TextBox 20"/>
+          <p:cNvSpPr txBox="1"/>
+          <p:nvPr/>
+        </p:nvSpPr>
+        <p:spPr>
+          <a:xfrm>
+            <a:off x="640080" y="6510528"/>
+            <a:ext cx="5486400" cy="274320"/>
+          </a:xfrm>
+          <a:prstGeom prst="rect">
+            <a:avLst/>
+          </a:prstGeom>
+          <a:noFill/>
+        </p:spPr>
+        <p:txBody>
+          <a:bodyPr wrap="square" lIns="0" rIns="0" tIns="0" bIns="0">
+            <a:spAutoFit/>
+          </a:bodyPr>
+          <a:lstStyle/>
+          <a:p>
+            <a:pPr algn="l"/>
+            <a:r>
+              <a:rPr sz="1000" b="0">
+                <a:solidFill>
+                  <a:srgbClr val="94A3B8"/>
+                </a:solidFill>
+                <a:latin typeface="Calibri"/>
+              </a:rPr>
+              <a:t>Deepfake Detection — Mid-Review Update</a:t>
+            </a:r>
+          </a:p>
+        </p:txBody>
+      </p:sp>
+      <p:sp>
+        <p:nvSpPr>
+          <p:cNvPr id="22" name="TextBox 21"/>
+          <p:cNvSpPr txBox="1"/>
+          <p:nvPr/>
+        </p:nvSpPr>
+        <p:spPr>
+          <a:xfrm>
+            <a:off x="10972800" y="6510528"/>
+            <a:ext cx="822960" cy="274320"/>
+          </a:xfrm>
+          <a:prstGeom prst="rect">
+            <a:avLst/>
+          </a:prstGeom>
+          <a:noFill/>
+        </p:spPr>
+        <p:txBody>
+          <a:bodyPr wrap="square" lIns="0" rIns="0" tIns="0" bIns="0">
+            <a:spAutoFit/>
+          </a:bodyPr>
+          <a:lstStyle/>
+          <a:p>
+            <a:pPr algn="l"/>
+            <a:r>
+              <a:rPr sz="1000" b="0">
+                <a:solidFill>
+                  <a:srgbClr val="94A3B8"/>
+                </a:solidFill>
+                <a:latin typeface="Calibri"/>
+              </a:rPr>
+              <a:t>8/9</a:t>
+            </a:r>
+          </a:p>
+        </p:txBody>
+      </p:sp>
+    </p:spTree>
+  </p:cSld>
+  <p:clrMapOvr>
+    <a:masterClrMapping/>
+  </p:clrMapOvr>
+</p:sld>
+</file>
+
+<file path=ppt/slides/slide9.xml><?xml version="1.0" encoding="utf-8"?>
+<p:sld xmlns:a="http://schemas.openxmlformats.org/drawingml/2006/main" xmlns:p="http://schemas.openxmlformats.org/presentationml/2006/main" xmlns:r="http://schemas.openxmlformats.org/officeDocument/2006/relationships">
+  <p:cSld>
+    <p:spTree>
+      <p:nvGrpSpPr>
+        <p:cNvPr id="1" name=""/>
+        <p:cNvGrpSpPr/>
+        <p:nvPr/>
+      </p:nvGrpSpPr>
+      <p:grpSpPr/>
+      <p:sp>
+        <p:nvSpPr>
+          <p:cNvPr id="2" name="Rectangle 1"/>
+          <p:cNvSpPr/>
+          <p:nvPr/>
+        </p:nvSpPr>
+        <p:spPr>
+          <a:xfrm>
+            <a:off x="0" y="0"/>
+            <a:ext cx="12191695" cy="6858000"/>
+          </a:xfrm>
+          <a:prstGeom prst="rect">
+            <a:avLst/>
+          </a:prstGeom>
+          <a:solidFill>
             <a:srgbClr val="0F172A"/>
           </a:solidFill>
           <a:ln>
@@ -10880,7 +11684,7 @@
                 </a:solidFill>
                 <a:latin typeface="Calibri"/>
               </a:rPr>
-              <a:t>8/8</a:t>
+              <a:t>9/9</a:t>
             </a:r>
           </a:p>
         </p:txBody>

</xml_diff>

<commit_message>
Add the other 3 team members to the mid-review deck
Team roster (name + roll no.) pulled from slides/build_mid_sem_ppt.py in
the Mondrian-Conformal-Prediction-On-Discrete-Event-Simulation repo, same
org -- same team works across both course projects. Title slide now lists
all four names; closing slide's contributor panel expanded from one person
to a compact 4-row list with roll numbers, reclaiming space from the
references block (which had more room than it needed).

Co-Authored-By: Claude Sonnet 5 <noreply@anthropic.com>
</commit_message>
<xml_diff>
--- a/docs/mid_review_update.pptx
+++ b/docs/mid_review_update.pptx
@@ -3356,7 +3356,7 @@
         <p:spPr>
           <a:xfrm>
             <a:off x="640080" y="5989320"/>
-            <a:ext cx="7315200" cy="320040"/>
+            <a:ext cx="10852800" cy="320040"/>
           </a:xfrm>
           <a:prstGeom prst="rect">
             <a:avLst/>
@@ -3377,7 +3377,7 @@
                 </a:solidFill>
                 <a:latin typeface="Calibri"/>
               </a:rPr>
-              <a:t>Venugopalan Gangadharan</a:t>
+              <a:t>Venugopalan Gangadharan · Vipin Sudhakar · Rithvik Arulprakash · Harshith Kv</a:t>
             </a:r>
           </a:p>
         </p:txBody>
@@ -4081,7 +4081,7 @@
         <p:spPr>
           <a:xfrm>
             <a:off x="7218680" y="2130000"/>
-            <a:ext cx="4332935" cy="1900000"/>
+            <a:ext cx="4332935" cy="950000"/>
           </a:xfrm>
           <a:prstGeom prst="rect">
             <a:avLst/>
@@ -4099,11 +4099,11 @@
                 <a:spcPct val="112000"/>
               </a:lnSpc>
               <a:spcAft>
-                <a:spcPts val="700"/>
+                <a:spcPts val="500"/>
               </a:spcAft>
             </a:pPr>
             <a:r>
-              <a:rPr sz="1050" b="0">
+              <a:rPr sz="1000" b="0">
                 <a:solidFill>
                   <a:srgbClr val="1A202C"/>
                 </a:solidFill>
@@ -4118,11 +4118,11 @@
                 <a:spcPct val="112000"/>
               </a:lnSpc>
               <a:spcAft>
-                <a:spcPts val="700"/>
+                <a:spcPts val="500"/>
               </a:spcAft>
             </a:pPr>
             <a:r>
-              <a:rPr sz="1050" b="0">
+              <a:rPr sz="1000" b="0">
                 <a:solidFill>
                   <a:srgbClr val="1A202C"/>
                 </a:solidFill>
@@ -4137,11 +4137,11 @@
                 <a:spcPct val="112000"/>
               </a:lnSpc>
               <a:spcAft>
-                <a:spcPts val="700"/>
+                <a:spcPts val="500"/>
               </a:spcAft>
             </a:pPr>
             <a:r>
-              <a:rPr sz="1050" b="0">
+              <a:rPr sz="1000" b="0">
                 <a:solidFill>
                   <a:srgbClr val="1A202C"/>
                 </a:solidFill>
@@ -4156,11 +4156,11 @@
                 <a:spcPct val="112000"/>
               </a:lnSpc>
               <a:spcAft>
-                <a:spcPts val="700"/>
+                <a:spcPts val="500"/>
               </a:spcAft>
             </a:pPr>
             <a:r>
-              <a:rPr sz="1050" b="0">
+              <a:rPr sz="1000" b="0">
                 <a:solidFill>
                   <a:srgbClr val="1A202C"/>
                 </a:solidFill>
@@ -4179,7 +4179,7 @@
         </p:nvSpPr>
         <p:spPr>
           <a:xfrm>
-            <a:off x="7218680" y="4100000"/>
+            <a:off x="7218680" y="3100000"/>
             <a:ext cx="4332935" cy="18288"/>
           </a:xfrm>
           <a:prstGeom prst="rect">
@@ -4223,7 +4223,7 @@
         </p:nvSpPr>
         <p:spPr>
           <a:xfrm>
-            <a:off x="7218680" y="4260000"/>
+            <a:off x="7218680" y="3260000"/>
             <a:ext cx="4332935" cy="320040"/>
           </a:xfrm>
           <a:prstGeom prst="rect">
@@ -4245,7 +4245,7 @@
                 </a:solidFill>
                 <a:latin typeface="Calibri"/>
               </a:rPr>
-              <a:t>CONTRIBUTOR</a:t>
+              <a:t>CONTRIBUTORS</a:t>
             </a:r>
           </a:p>
         </p:txBody>
@@ -4258,8 +4258,8 @@
         </p:nvSpPr>
         <p:spPr>
           <a:xfrm>
-            <a:off x="7218680" y="4560000"/>
-            <a:ext cx="4332935" cy="360000"/>
+            <a:off x="7218680" y="3600000"/>
+            <a:ext cx="4332935" cy="1080000"/>
           </a:xfrm>
           <a:prstGeom prst="rect">
             <a:avLst/>
@@ -4272,15 +4272,79 @@
           </a:bodyPr>
           <a:lstStyle/>
           <a:p>
-            <a:pPr algn="l"/>
-            <a:r>
-              <a:rPr sz="1400" b="1">
+            <a:pPr>
+              <a:lnSpc>
+                <a:spcPct val="112000"/>
+              </a:lnSpc>
+              <a:spcAft>
+                <a:spcPts val="600"/>
+              </a:spcAft>
+            </a:pPr>
+            <a:r>
+              <a:rPr sz="1050" b="1">
                 <a:solidFill>
                   <a:srgbClr val="1A202C"/>
                 </a:solidFill>
                 <a:latin typeface="Calibri"/>
               </a:rPr>
-              <a:t>Venugopalan Gangadharan</a:t>
+              <a:t>▸  Venugopalan Gangadharan — CB.AI.U4AID25115</a:t>
+            </a:r>
+          </a:p>
+          <a:p>
+            <a:pPr>
+              <a:lnSpc>
+                <a:spcPct val="112000"/>
+              </a:lnSpc>
+              <a:spcAft>
+                <a:spcPts val="600"/>
+              </a:spcAft>
+            </a:pPr>
+            <a:r>
+              <a:rPr sz="1050" b="1">
+                <a:solidFill>
+                  <a:srgbClr val="1A202C"/>
+                </a:solidFill>
+                <a:latin typeface="Calibri"/>
+              </a:rPr>
+              <a:t>▸  Vipin Sudhakar — CB.AI.U4AID25166</a:t>
+            </a:r>
+          </a:p>
+          <a:p>
+            <a:pPr>
+              <a:lnSpc>
+                <a:spcPct val="112000"/>
+              </a:lnSpc>
+              <a:spcAft>
+                <a:spcPts val="600"/>
+              </a:spcAft>
+            </a:pPr>
+            <a:r>
+              <a:rPr sz="1050" b="1">
+                <a:solidFill>
+                  <a:srgbClr val="1A202C"/>
+                </a:solidFill>
+                <a:latin typeface="Calibri"/>
+              </a:rPr>
+              <a:t>▸  Rithvik Arulprakash — CB.AI.U4AID25148</a:t>
+            </a:r>
+          </a:p>
+          <a:p>
+            <a:pPr>
+              <a:lnSpc>
+                <a:spcPct val="112000"/>
+              </a:lnSpc>
+              <a:spcAft>
+                <a:spcPts val="600"/>
+              </a:spcAft>
+            </a:pPr>
+            <a:r>
+              <a:rPr sz="1050" b="1">
+                <a:solidFill>
+                  <a:srgbClr val="1A202C"/>
+                </a:solidFill>
+                <a:latin typeface="Calibri"/>
+              </a:rPr>
+              <a:t>▸  Harshith Kv — CB.AI.U4AID25119</a:t>
             </a:r>
           </a:p>
         </p:txBody>
@@ -4293,8 +4357,8 @@
         </p:nvSpPr>
         <p:spPr>
           <a:xfrm>
-            <a:off x="7218680" y="4910000"/>
-            <a:ext cx="4332935" cy="500000"/>
+            <a:off x="7218680" y="4700000"/>
+            <a:ext cx="4332935" cy="360000"/>
           </a:xfrm>
           <a:prstGeom prst="rect">
             <a:avLst/>
@@ -4309,7 +4373,7 @@
           <a:p>
             <a:pPr algn="l"/>
             <a:r>
-              <a:rPr sz="1050" b="0">
+              <a:rPr sz="1000" b="0">
                 <a:solidFill>
                   <a:srgbClr val="475569"/>
                 </a:solidFill>
@@ -4328,7 +4392,7 @@
         </p:nvSpPr>
         <p:spPr>
           <a:xfrm>
-            <a:off x="7218680" y="5450000"/>
+            <a:off x="7218680" y="5150000"/>
             <a:ext cx="4332935" cy="320040"/>
           </a:xfrm>
           <a:prstGeom prst="rect">
@@ -4363,7 +4427,7 @@
         </p:nvSpPr>
         <p:spPr>
           <a:xfrm>
-            <a:off x="7218680" y="5750000"/>
+            <a:off x="7218680" y="5450000"/>
             <a:ext cx="4332935" cy="500000"/>
           </a:xfrm>
           <a:prstGeom prst="rect">

</xml_diff>